<commit_message>
Add architecture diagram to submission PPT slide.
</commit_message>
<xml_diff>
--- a/submission/SRM_ThinkLoop_Submission.pptx
+++ b/submission/SRM_ThinkLoop_Submission.pptx
@@ -14473,8 +14473,8 @@
         </p:nvSpPr>
         <p:spPr>
           <a:xfrm>
-            <a:off x="838200" y="1825625"/>
-            <a:ext cx="10515600" cy="4351338"/>
+            <a:off x="365760" y="320040"/>
+            <a:ext cx="8412480" cy="868680"/>
           </a:xfrm>
           <a:prstGeom prst="rect">
             <a:avLst/>
@@ -14507,12 +14507,47 @@
               <a:buNone/>
             </a:pPr>
             <a:r>
-              <a:t/>
+              <a:rPr sz="2000" b="1">
+                <a:latin typeface="Calibri"/>
+              </a:rPr>
+              <a:t>Our Solution &amp; Architecture Diagram</a:t>
             </a:r>
             <a:endParaRPr/>
           </a:p>
+          <a:p>
+            <a:r>
+              <a:rPr sz="1100">
+                <a:latin typeface="Calibri"/>
+              </a:rPr>
+              <a:t>FastAPI pipeline with Gemini planning, SIIS grounding, hybrid retrieval, repair/validate, extractive fallback, and warm cache. Live on Render (Docker).</a:t>
+            </a:r>
+          </a:p>
         </p:txBody>
       </p:sp>
+      <p:pic>
+        <p:nvPicPr>
+          <p:cNvPr id="115" name="Picture 114" descr="architecture_diagram.png"/>
+          <p:cNvPicPr>
+            <a:picLocks noChangeAspect="1"/>
+          </p:cNvPicPr>
+          <p:nvPr/>
+        </p:nvPicPr>
+        <p:blipFill>
+          <a:blip r:embed="rId3"/>
+          <a:stretch>
+            <a:fillRect/>
+          </a:stretch>
+        </p:blipFill>
+        <p:spPr>
+          <a:xfrm>
+            <a:off x="228600" y="1234440"/>
+            <a:ext cx="8686800" cy="4886325"/>
+          </a:xfrm>
+          <a:prstGeom prst="rect">
+            <a:avLst/>
+          </a:prstGeom>
+        </p:spPr>
+      </p:pic>
     </p:spTree>
   </p:cSld>
   <p:clrMapOvr>

</xml_diff>